<commit_message>
Regenerate the ink deck and its reference with the pressure cases
Co-Authored-By: Claude Opus 5.5 <noreply@anthropic.com>
</commit_message>
<xml_diff>
--- a/tests/corpus/pptx/generated/ink.pptx
+++ b/tests/corpus/pptx/generated/ink.pptx
@@ -123,6 +123,21 @@
       </inkml:inkSource>
       <inkml:timestamp xml:id="ts0" timeString="2024-01-01T12:00:00.000"/>
     </inkml:context>
+    <inkml:context xml:id="ctx1">
+      <inkml:inkSource xml:id="inkSrc1">
+        <inkml:traceFormat>
+          <inkml:channel name="X" type="integer" max="32767" units="cm"/>
+          <inkml:channel name="Y" type="integer" max="32767" units="cm"/>
+          <inkml:channel name="F" type="integer" max="32767" units="dev"/>
+        </inkml:traceFormat>
+        <inkml:channelProperties>
+          <inkml:channelProperty channel="X" name="resolution" value="1000" units="1/cm"/>
+          <inkml:channelProperty channel="Y" name="resolution" value="1000" units="1/cm"/>
+          <inkml:channelProperty channel="F" name="resolution" value="0" units="1/dev"/>
+        </inkml:channelProperties>
+      </inkml:inkSource>
+      <inkml:timestamp xml:id="ts1" timeString="2024-01-01T12:00:00.000"/>
+    </inkml:context>
     <inkml:brush xml:id="b">
       <inkml:brushProperty name="width" value="0.2" units="cm"/>
       <inkml:brushProperty name="height" value="0.2" units="cm"/>
@@ -130,6 +145,171 @@
     </inkml:brush>
   </inkml:definitions>
   <inkml:trace contextRef="#ctx0" brushRef="#b">2000 2000, 3000 3500, 4000 2000, 5000 3500, 6000 2000</inkml:trace>
+</inkml:ink>
+</file>
+
+<file path=ppt/ink/ink10.xml><?xml version="1.0" encoding="utf-8"?>
+<inkml:ink xmlns:inkml="http://www.w3.org/2003/InkML">
+  <inkml:definitions>
+    <inkml:context xml:id="ctx0">
+      <inkml:inkSource xml:id="inkSrc0">
+        <inkml:traceFormat>
+          <inkml:channel name="X" type="integer" max="32767" units="cm"/>
+          <inkml:channel name="Y" type="integer" max="32767" units="cm"/>
+        </inkml:traceFormat>
+        <inkml:channelProperties>
+          <inkml:channelProperty channel="X" name="resolution" value="1000" units="1/cm"/>
+          <inkml:channelProperty channel="Y" name="resolution" value="1000" units="1/cm"/>
+        </inkml:channelProperties>
+      </inkml:inkSource>
+      <inkml:timestamp xml:id="ts0" timeString="2024-01-01T12:00:00.000"/>
+    </inkml:context>
+    <inkml:context xml:id="ctx1">
+      <inkml:inkSource xml:id="inkSrc1">
+        <inkml:traceFormat>
+          <inkml:channel name="X" type="integer" max="32767" units="cm"/>
+          <inkml:channel name="Y" type="integer" max="32767" units="cm"/>
+          <inkml:channel name="F" type="integer" max="32767" units="dev"/>
+        </inkml:traceFormat>
+        <inkml:channelProperties>
+          <inkml:channelProperty channel="X" name="resolution" value="1000" units="1/cm"/>
+          <inkml:channelProperty channel="Y" name="resolution" value="1000" units="1/cm"/>
+          <inkml:channelProperty channel="F" name="resolution" value="0" units="1/dev"/>
+        </inkml:channelProperties>
+      </inkml:inkSource>
+      <inkml:timestamp xml:id="ts1" timeString="2024-01-01T12:00:00.000"/>
+    </inkml:context>
+    <inkml:brush xml:id="b">
+      <inkml:brushProperty name="width" value="0.4" units="cm"/>
+      <inkml:brushProperty name="height" value="0.4" units="cm"/>
+      <inkml:brushProperty name="color" value="#E71224"/>
+    </inkml:brush>
+  </inkml:definitions>
+  <inkml:trace contextRef="#ctx1" brushRef="#b">26500 4000 32767, 29500 4000 32767, 32500 4000 32767</inkml:trace>
+</inkml:ink>
+</file>
+
+<file path=ppt/ink/ink11.xml><?xml version="1.0" encoding="utf-8"?>
+<inkml:ink xmlns:inkml="http://www.w3.org/2003/InkML">
+  <inkml:definitions>
+    <inkml:context xml:id="ctx0">
+      <inkml:inkSource xml:id="inkSrc0">
+        <inkml:traceFormat>
+          <inkml:channel name="X" type="integer" max="32767" units="cm"/>
+          <inkml:channel name="Y" type="integer" max="32767" units="cm"/>
+        </inkml:traceFormat>
+        <inkml:channelProperties>
+          <inkml:channelProperty channel="X" name="resolution" value="1000" units="1/cm"/>
+          <inkml:channelProperty channel="Y" name="resolution" value="1000" units="1/cm"/>
+        </inkml:channelProperties>
+      </inkml:inkSource>
+      <inkml:timestamp xml:id="ts0" timeString="2024-01-01T12:00:00.000"/>
+    </inkml:context>
+    <inkml:context xml:id="ctx1">
+      <inkml:inkSource xml:id="inkSrc1">
+        <inkml:traceFormat>
+          <inkml:channel name="X" type="integer" max="32767" units="cm"/>
+          <inkml:channel name="Y" type="integer" max="32767" units="cm"/>
+          <inkml:channel name="F" type="integer" max="32767" units="dev"/>
+        </inkml:traceFormat>
+        <inkml:channelProperties>
+          <inkml:channelProperty channel="X" name="resolution" value="1000" units="1/cm"/>
+          <inkml:channelProperty channel="Y" name="resolution" value="1000" units="1/cm"/>
+          <inkml:channelProperty channel="F" name="resolution" value="0" units="1/dev"/>
+        </inkml:channelProperties>
+      </inkml:inkSource>
+      <inkml:timestamp xml:id="ts1" timeString="2024-01-01T12:00:00.000"/>
+    </inkml:context>
+    <inkml:brush xml:id="b">
+      <inkml:brushProperty name="width" value="0.4" units="cm"/>
+      <inkml:brushProperty name="height" value="0.4" units="cm"/>
+      <inkml:brushProperty name="color" value="#E71224"/>
+    </inkml:brush>
+  </inkml:definitions>
+  <inkml:trace contextRef="#ctx1" brushRef="#b">26500 6000 8192, 29500 6000 8192, 32500 6000 8192</inkml:trace>
+</inkml:ink>
+</file>
+
+<file path=ppt/ink/ink12.xml><?xml version="1.0" encoding="utf-8"?>
+<inkml:ink xmlns:inkml="http://www.w3.org/2003/InkML">
+  <inkml:definitions>
+    <inkml:context xml:id="ctx0">
+      <inkml:inkSource xml:id="inkSrc0">
+        <inkml:traceFormat>
+          <inkml:channel name="X" type="integer" max="32767" units="cm"/>
+          <inkml:channel name="Y" type="integer" max="32767" units="cm"/>
+        </inkml:traceFormat>
+        <inkml:channelProperties>
+          <inkml:channelProperty channel="X" name="resolution" value="1000" units="1/cm"/>
+          <inkml:channelProperty channel="Y" name="resolution" value="1000" units="1/cm"/>
+        </inkml:channelProperties>
+      </inkml:inkSource>
+      <inkml:timestamp xml:id="ts0" timeString="2024-01-01T12:00:00.000"/>
+    </inkml:context>
+    <inkml:context xml:id="ctx1">
+      <inkml:inkSource xml:id="inkSrc1">
+        <inkml:traceFormat>
+          <inkml:channel name="X" type="integer" max="32767" units="cm"/>
+          <inkml:channel name="Y" type="integer" max="32767" units="cm"/>
+          <inkml:channel name="F" type="integer" max="32767" units="dev"/>
+        </inkml:traceFormat>
+        <inkml:channelProperties>
+          <inkml:channelProperty channel="X" name="resolution" value="1000" units="1/cm"/>
+          <inkml:channelProperty channel="Y" name="resolution" value="1000" units="1/cm"/>
+          <inkml:channelProperty channel="F" name="resolution" value="0" units="1/dev"/>
+        </inkml:channelProperties>
+      </inkml:inkSource>
+      <inkml:timestamp xml:id="ts1" timeString="2024-01-01T12:00:00.000"/>
+    </inkml:context>
+    <inkml:brush xml:id="b">
+      <inkml:brushProperty name="width" value="0.4" units="cm"/>
+      <inkml:brushProperty name="height" value="0.4" units="cm"/>
+      <inkml:brushProperty name="color" value="#0070C0"/>
+      <inkml:brushProperty name="ignorePressure" value="1"/>
+    </inkml:brush>
+  </inkml:definitions>
+  <inkml:trace contextRef="#ctx1" brushRef="#b">26500 8000 32767, 29500 8000 32767, 32500 8000 32767</inkml:trace>
+</inkml:ink>
+</file>
+
+<file path=ppt/ink/ink13.xml><?xml version="1.0" encoding="utf-8"?>
+<inkml:ink xmlns:inkml="http://www.w3.org/2003/InkML">
+  <inkml:definitions>
+    <inkml:context xml:id="ctx0">
+      <inkml:inkSource xml:id="inkSrc0">
+        <inkml:traceFormat>
+          <inkml:channel name="X" type="integer" max="32767" units="cm"/>
+          <inkml:channel name="Y" type="integer" max="32767" units="cm"/>
+        </inkml:traceFormat>
+        <inkml:channelProperties>
+          <inkml:channelProperty channel="X" name="resolution" value="1000" units="1/cm"/>
+          <inkml:channelProperty channel="Y" name="resolution" value="1000" units="1/cm"/>
+        </inkml:channelProperties>
+      </inkml:inkSource>
+      <inkml:timestamp xml:id="ts0" timeString="2024-01-01T12:00:00.000"/>
+    </inkml:context>
+    <inkml:context xml:id="ctx1">
+      <inkml:inkSource xml:id="inkSrc1">
+        <inkml:traceFormat>
+          <inkml:channel name="X" type="integer" max="32767" units="cm"/>
+          <inkml:channel name="Y" type="integer" max="32767" units="cm"/>
+          <inkml:channel name="F" type="integer" max="32767" units="dev"/>
+        </inkml:traceFormat>
+        <inkml:channelProperties>
+          <inkml:channelProperty channel="X" name="resolution" value="1000" units="1/cm"/>
+          <inkml:channelProperty channel="Y" name="resolution" value="1000" units="1/cm"/>
+          <inkml:channelProperty channel="F" name="resolution" value="0" units="1/dev"/>
+        </inkml:channelProperties>
+      </inkml:inkSource>
+      <inkml:timestamp xml:id="ts1" timeString="2024-01-01T12:00:00.000"/>
+    </inkml:context>
+    <inkml:brush xml:id="b">
+      <inkml:brushProperty name="width" value="0.3" units="cm"/>
+      <inkml:brushProperty name="height" value="0.3" units="cm"/>
+      <inkml:brushProperty name="color" value="#7030A0"/>
+    </inkml:brush>
+  </inkml:definitions>
+  <inkml:trace contextRef="#ctx1" brushRef="#b">26500 10000 4000, 28000 11500 32767, 29500 10000 4000, 31000 11500 32767, 32500 10000 4000</inkml:trace>
 </inkml:ink>
 </file>
 
@@ -148,6 +328,21 @@
         </inkml:channelProperties>
       </inkml:inkSource>
       <inkml:timestamp xml:id="ts0" timeString="2024-01-01T12:00:00.000"/>
+    </inkml:context>
+    <inkml:context xml:id="ctx1">
+      <inkml:inkSource xml:id="inkSrc1">
+        <inkml:traceFormat>
+          <inkml:channel name="X" type="integer" max="32767" units="cm"/>
+          <inkml:channel name="Y" type="integer" max="32767" units="cm"/>
+          <inkml:channel name="F" type="integer" max="32767" units="dev"/>
+        </inkml:traceFormat>
+        <inkml:channelProperties>
+          <inkml:channelProperty channel="X" name="resolution" value="1000" units="1/cm"/>
+          <inkml:channelProperty channel="Y" name="resolution" value="1000" units="1/cm"/>
+          <inkml:channelProperty channel="F" name="resolution" value="0" units="1/dev"/>
+        </inkml:channelProperties>
+      </inkml:inkSource>
+      <inkml:timestamp xml:id="ts1" timeString="2024-01-01T12:00:00.000"/>
     </inkml:context>
     <inkml:brush xml:id="b">
       <inkml:brushProperty name="width" value="0.2" units="cm"/>
@@ -175,6 +370,21 @@
       </inkml:inkSource>
       <inkml:timestamp xml:id="ts0" timeString="2024-01-01T12:00:00.000"/>
     </inkml:context>
+    <inkml:context xml:id="ctx1">
+      <inkml:inkSource xml:id="inkSrc1">
+        <inkml:traceFormat>
+          <inkml:channel name="X" type="integer" max="32767" units="cm"/>
+          <inkml:channel name="Y" type="integer" max="32767" units="cm"/>
+          <inkml:channel name="F" type="integer" max="32767" units="dev"/>
+        </inkml:traceFormat>
+        <inkml:channelProperties>
+          <inkml:channelProperty channel="X" name="resolution" value="1000" units="1/cm"/>
+          <inkml:channelProperty channel="Y" name="resolution" value="1000" units="1/cm"/>
+          <inkml:channelProperty channel="F" name="resolution" value="0" units="1/dev"/>
+        </inkml:channelProperties>
+      </inkml:inkSource>
+      <inkml:timestamp xml:id="ts1" timeString="2024-01-01T12:00:00.000"/>
+    </inkml:context>
     <inkml:brush xml:id="b">
       <inkml:brushProperty name="width" value="0.2" units="cm"/>
       <inkml:brushProperty name="height" value="0.2" units="cm"/>
@@ -201,6 +411,21 @@
       </inkml:inkSource>
       <inkml:timestamp xml:id="ts0" timeString="2024-01-01T12:00:00.000"/>
     </inkml:context>
+    <inkml:context xml:id="ctx1">
+      <inkml:inkSource xml:id="inkSrc1">
+        <inkml:traceFormat>
+          <inkml:channel name="X" type="integer" max="32767" units="cm"/>
+          <inkml:channel name="Y" type="integer" max="32767" units="cm"/>
+          <inkml:channel name="F" type="integer" max="32767" units="dev"/>
+        </inkml:traceFormat>
+        <inkml:channelProperties>
+          <inkml:channelProperty channel="X" name="resolution" value="1000" units="1/cm"/>
+          <inkml:channelProperty channel="Y" name="resolution" value="1000" units="1/cm"/>
+          <inkml:channelProperty channel="F" name="resolution" value="0" units="1/dev"/>
+        </inkml:channelProperties>
+      </inkml:inkSource>
+      <inkml:timestamp xml:id="ts1" timeString="2024-01-01T12:00:00.000"/>
+    </inkml:context>
     <inkml:brush xml:id="b">
       <inkml:brushProperty name="width" value="0.2" units="cm"/>
       <inkml:brushProperty name="height" value="0.2" units="cm"/>
@@ -226,6 +451,21 @@
         </inkml:channelProperties>
       </inkml:inkSource>
       <inkml:timestamp xml:id="ts0" timeString="2024-01-01T12:00:00.000"/>
+    </inkml:context>
+    <inkml:context xml:id="ctx1">
+      <inkml:inkSource xml:id="inkSrc1">
+        <inkml:traceFormat>
+          <inkml:channel name="X" type="integer" max="32767" units="cm"/>
+          <inkml:channel name="Y" type="integer" max="32767" units="cm"/>
+          <inkml:channel name="F" type="integer" max="32767" units="dev"/>
+        </inkml:traceFormat>
+        <inkml:channelProperties>
+          <inkml:channelProperty channel="X" name="resolution" value="1000" units="1/cm"/>
+          <inkml:channelProperty channel="Y" name="resolution" value="1000" units="1/cm"/>
+          <inkml:channelProperty channel="F" name="resolution" value="0" units="1/dev"/>
+        </inkml:channelProperties>
+      </inkml:inkSource>
+      <inkml:timestamp xml:id="ts1" timeString="2024-01-01T12:00:00.000"/>
     </inkml:context>
     <inkml:brush xml:id="b">
       <inkml:brushProperty name="width" value="0.2" units="cm"/>
@@ -259,6 +499,21 @@
       </inkml:inkSource>
       <inkml:timestamp xml:id="ts0" timeString="2024-01-01T12:00:00.000"/>
     </inkml:context>
+    <inkml:context xml:id="ctx1">
+      <inkml:inkSource xml:id="inkSrc1">
+        <inkml:traceFormat>
+          <inkml:channel name="X" type="integer" max="32767" units="cm"/>
+          <inkml:channel name="Y" type="integer" max="32767" units="cm"/>
+          <inkml:channel name="F" type="integer" max="32767" units="dev"/>
+        </inkml:traceFormat>
+        <inkml:channelProperties>
+          <inkml:channelProperty channel="X" name="resolution" value="1000" units="1/cm"/>
+          <inkml:channelProperty channel="Y" name="resolution" value="1000" units="1/cm"/>
+          <inkml:channelProperty channel="F" name="resolution" value="0" units="1/dev"/>
+        </inkml:channelProperties>
+      </inkml:inkSource>
+      <inkml:timestamp xml:id="ts1" timeString="2024-01-01T12:00:00.000"/>
+    </inkml:context>
     <inkml:brush xml:id="b">
       <inkml:brushProperty name="width" value="0.05" units="cm"/>
       <inkml:brushProperty name="height" value="0.05" units="cm"/>
@@ -284,6 +539,21 @@
         </inkml:channelProperties>
       </inkml:inkSource>
       <inkml:timestamp xml:id="ts0" timeString="2024-01-01T12:00:00.000"/>
+    </inkml:context>
+    <inkml:context xml:id="ctx1">
+      <inkml:inkSource xml:id="inkSrc1">
+        <inkml:traceFormat>
+          <inkml:channel name="X" type="integer" max="32767" units="cm"/>
+          <inkml:channel name="Y" type="integer" max="32767" units="cm"/>
+          <inkml:channel name="F" type="integer" max="32767" units="dev"/>
+        </inkml:traceFormat>
+        <inkml:channelProperties>
+          <inkml:channelProperty channel="X" name="resolution" value="1000" units="1/cm"/>
+          <inkml:channelProperty channel="Y" name="resolution" value="1000" units="1/cm"/>
+          <inkml:channelProperty channel="F" name="resolution" value="0" units="1/dev"/>
+        </inkml:channelProperties>
+      </inkml:inkSource>
+      <inkml:timestamp xml:id="ts1" timeString="2024-01-01T12:00:00.000"/>
     </inkml:context>
     <inkml:brush xml:id="b">
       <inkml:brushProperty name="width" value="0.6" units="cm"/>
@@ -313,6 +583,21 @@
       </inkml:inkSource>
       <inkml:timestamp xml:id="ts0" timeString="2024-01-01T12:00:00.000"/>
     </inkml:context>
+    <inkml:context xml:id="ctx1">
+      <inkml:inkSource xml:id="inkSrc1">
+        <inkml:traceFormat>
+          <inkml:channel name="X" type="integer" max="32767" units="cm"/>
+          <inkml:channel name="Y" type="integer" max="32767" units="cm"/>
+          <inkml:channel name="F" type="integer" max="32767" units="dev"/>
+        </inkml:traceFormat>
+        <inkml:channelProperties>
+          <inkml:channelProperty channel="X" name="resolution" value="1000" units="1/cm"/>
+          <inkml:channelProperty channel="Y" name="resolution" value="1000" units="1/cm"/>
+          <inkml:channelProperty channel="F" name="resolution" value="0" units="1/dev"/>
+        </inkml:channelProperties>
+      </inkml:inkSource>
+      <inkml:timestamp xml:id="ts1" timeString="2024-01-01T12:00:00.000"/>
+    </inkml:context>
     <inkml:brush xml:id="b">
       <inkml:brushProperty name="width" value="0.6" units="cm"/>
       <inkml:brushProperty name="height" value="0.6" units="cm"/>
@@ -328,6 +613,47 @@
   </inkml:definitions>
   <inkml:trace contextRef="#ctx0" brushRef="#b">16000 12000, 24000 12000</inkml:trace>
   <inkml:trace contextRef="#ctx0" brushRef="#c">16000 13000, 18000 14000, 20000 13000</inkml:trace>
+</inkml:ink>
+</file>
+
+<file path=ppt/ink/ink9.xml><?xml version="1.0" encoding="utf-8"?>
+<inkml:ink xmlns:inkml="http://www.w3.org/2003/InkML">
+  <inkml:definitions>
+    <inkml:context xml:id="ctx0">
+      <inkml:inkSource xml:id="inkSrc0">
+        <inkml:traceFormat>
+          <inkml:channel name="X" type="integer" max="32767" units="cm"/>
+          <inkml:channel name="Y" type="integer" max="32767" units="cm"/>
+        </inkml:traceFormat>
+        <inkml:channelProperties>
+          <inkml:channelProperty channel="X" name="resolution" value="1000" units="1/cm"/>
+          <inkml:channelProperty channel="Y" name="resolution" value="1000" units="1/cm"/>
+        </inkml:channelProperties>
+      </inkml:inkSource>
+      <inkml:timestamp xml:id="ts0" timeString="2024-01-01T12:00:00.000"/>
+    </inkml:context>
+    <inkml:context xml:id="ctx1">
+      <inkml:inkSource xml:id="inkSrc1">
+        <inkml:traceFormat>
+          <inkml:channel name="X" type="integer" max="32767" units="cm"/>
+          <inkml:channel name="Y" type="integer" max="32767" units="cm"/>
+          <inkml:channel name="F" type="integer" max="32767" units="dev"/>
+        </inkml:traceFormat>
+        <inkml:channelProperties>
+          <inkml:channelProperty channel="X" name="resolution" value="1000" units="1/cm"/>
+          <inkml:channelProperty channel="Y" name="resolution" value="1000" units="1/cm"/>
+          <inkml:channelProperty channel="F" name="resolution" value="0" units="1/dev"/>
+        </inkml:channelProperties>
+      </inkml:inkSource>
+      <inkml:timestamp xml:id="ts1" timeString="2024-01-01T12:00:00.000"/>
+    </inkml:context>
+    <inkml:brush xml:id="b">
+      <inkml:brushProperty name="width" value="0.4" units="cm"/>
+      <inkml:brushProperty name="height" value="0.4" units="cm"/>
+      <inkml:brushProperty name="color" value="#E71224"/>
+    </inkml:brush>
+  </inkml:definitions>
+  <inkml:trace contextRef="#ctx1" brushRef="#b">26500 2000 0, 28000 2000 8192, 29500 2000 16384, 31000 2000 24576, 32500 2000 32767</inkml:trace>
 </inkml:ink>
 </file>
 
@@ -353,7 +679,7 @@
           <p:cNvPr id="2" name="Titel 1">
             <a:extLst>
               <a:ext uri="{FF2B5EF4-FFF2-40B4-BE49-F238E27FC236}">
-                <a16:creationId xmlns:a16="http://schemas.microsoft.com/office/drawing/2014/main" id="{3E8F7182-0215-B7B8-4E0B-F9D98D406F76}"/>
+                <a16:creationId xmlns:a16="http://schemas.microsoft.com/office/drawing/2014/main" id="{04839892-736A-A9B0-85B9-4CC6D7198421}"/>
               </a:ext>
             </a:extLst>
           </p:cNvPr>
@@ -390,7 +716,7 @@
           <p:cNvPr id="3" name="Untertitel 2">
             <a:extLst>
               <a:ext uri="{FF2B5EF4-FFF2-40B4-BE49-F238E27FC236}">
-                <a16:creationId xmlns:a16="http://schemas.microsoft.com/office/drawing/2014/main" id="{5132F515-0217-627E-07E2-96DF219B47F4}"/>
+                <a16:creationId xmlns:a16="http://schemas.microsoft.com/office/drawing/2014/main" id="{57115E18-0328-4E07-425E-9104DB40D823}"/>
               </a:ext>
             </a:extLst>
           </p:cNvPr>
@@ -460,7 +786,7 @@
           <p:cNvPr id="4" name="Datumsplatzhalter 3">
             <a:extLst>
               <a:ext uri="{FF2B5EF4-FFF2-40B4-BE49-F238E27FC236}">
-                <a16:creationId xmlns:a16="http://schemas.microsoft.com/office/drawing/2014/main" id="{FEEFA24E-1103-FAE5-5DF4-36923778352A}"/>
+                <a16:creationId xmlns:a16="http://schemas.microsoft.com/office/drawing/2014/main" id="{2E510FF9-665B-4FA8-3C36-EEE8D5D853E4}"/>
               </a:ext>
             </a:extLst>
           </p:cNvPr>
@@ -476,7 +802,7 @@
           <a:bodyPr/>
           <a:lstStyle/>
           <a:p>
-            <a:fld id="{0F808190-ECEE-4405-8762-B79C9CB8530E}" type="datetimeFigureOut">
+            <a:fld id="{C50E988D-1B93-4C32-8AF0-3823B3639D11}" type="datetimeFigureOut">
               <a:rPr lang="de-DE" smtClean="0"/>
               <a:t>08.10.2026</a:t>
             </a:fld>
@@ -489,7 +815,7 @@
           <p:cNvPr id="5" name="Fußzeilenplatzhalter 4">
             <a:extLst>
               <a:ext uri="{FF2B5EF4-FFF2-40B4-BE49-F238E27FC236}">
-                <a16:creationId xmlns:a16="http://schemas.microsoft.com/office/drawing/2014/main" id="{A0B9AEF6-ECA7-5375-9D2A-9219CD2644E3}"/>
+                <a16:creationId xmlns:a16="http://schemas.microsoft.com/office/drawing/2014/main" id="{A04D9BCD-02E6-0E3A-19DF-DDF9D57DB441}"/>
               </a:ext>
             </a:extLst>
           </p:cNvPr>
@@ -514,7 +840,7 @@
           <p:cNvPr id="6" name="Foliennummernplatzhalter 5">
             <a:extLst>
               <a:ext uri="{FF2B5EF4-FFF2-40B4-BE49-F238E27FC236}">
-                <a16:creationId xmlns:a16="http://schemas.microsoft.com/office/drawing/2014/main" id="{FAE9B31B-F227-680B-1A5B-4A0F8BB39189}"/>
+                <a16:creationId xmlns:a16="http://schemas.microsoft.com/office/drawing/2014/main" id="{BFD2934C-27E7-BA84-ED0B-6283DFD0A54F}"/>
               </a:ext>
             </a:extLst>
           </p:cNvPr>
@@ -530,7 +856,7 @@
           <a:bodyPr/>
           <a:lstStyle/>
           <a:p>
-            <a:fld id="{0EFEE498-A838-455C-A0C1-5F48ABA5D83C}" type="slidenum">
+            <a:fld id="{D661D80D-627D-4426-A21E-9522BBF9A65E}" type="slidenum">
               <a:rPr lang="de-DE" smtClean="0"/>
               <a:t>‹Nr.›</a:t>
             </a:fld>
@@ -541,7 +867,7 @@
     </p:spTree>
     <p:extLst>
       <p:ext uri="{BB962C8B-B14F-4D97-AF65-F5344CB8AC3E}">
-        <p14:creationId xmlns:p14="http://schemas.microsoft.com/office/powerpoint/2010/main" val="1187254612"/>
+        <p14:creationId xmlns:p14="http://schemas.microsoft.com/office/powerpoint/2010/main" val="1660306364"/>
       </p:ext>
     </p:extLst>
   </p:cSld>
@@ -573,7 +899,7 @@
           <p:cNvPr id="2" name="Titel 1">
             <a:extLst>
               <a:ext uri="{FF2B5EF4-FFF2-40B4-BE49-F238E27FC236}">
-                <a16:creationId xmlns:a16="http://schemas.microsoft.com/office/drawing/2014/main" id="{63D55422-2CB7-9B09-37AB-512EA8BB131E}"/>
+                <a16:creationId xmlns:a16="http://schemas.microsoft.com/office/drawing/2014/main" id="{D4E469AC-9FC8-488F-F8F6-5E875DA01F06}"/>
               </a:ext>
             </a:extLst>
           </p:cNvPr>
@@ -601,7 +927,7 @@
           <p:cNvPr id="3" name="Vertikaler Textplatzhalter 2">
             <a:extLst>
               <a:ext uri="{FF2B5EF4-FFF2-40B4-BE49-F238E27FC236}">
-                <a16:creationId xmlns:a16="http://schemas.microsoft.com/office/drawing/2014/main" id="{A8BBC50E-D1BF-B152-CE49-CFF69D8D6185}"/>
+                <a16:creationId xmlns:a16="http://schemas.microsoft.com/office/drawing/2014/main" id="{BCDEC1F0-3F80-61CF-CA62-EB049C1E3A51}"/>
               </a:ext>
             </a:extLst>
           </p:cNvPr>
@@ -658,7 +984,7 @@
           <p:cNvPr id="4" name="Datumsplatzhalter 3">
             <a:extLst>
               <a:ext uri="{FF2B5EF4-FFF2-40B4-BE49-F238E27FC236}">
-                <a16:creationId xmlns:a16="http://schemas.microsoft.com/office/drawing/2014/main" id="{C804A387-1A42-F033-A278-E8FFA2BBF371}"/>
+                <a16:creationId xmlns:a16="http://schemas.microsoft.com/office/drawing/2014/main" id="{0FCD1844-E3F9-CA1F-40B4-62BA80689334}"/>
               </a:ext>
             </a:extLst>
           </p:cNvPr>
@@ -674,7 +1000,7 @@
           <a:bodyPr/>
           <a:lstStyle/>
           <a:p>
-            <a:fld id="{0F808190-ECEE-4405-8762-B79C9CB8530E}" type="datetimeFigureOut">
+            <a:fld id="{C50E988D-1B93-4C32-8AF0-3823B3639D11}" type="datetimeFigureOut">
               <a:rPr lang="de-DE" smtClean="0"/>
               <a:t>08.10.2026</a:t>
             </a:fld>
@@ -687,7 +1013,7 @@
           <p:cNvPr id="5" name="Fußzeilenplatzhalter 4">
             <a:extLst>
               <a:ext uri="{FF2B5EF4-FFF2-40B4-BE49-F238E27FC236}">
-                <a16:creationId xmlns:a16="http://schemas.microsoft.com/office/drawing/2014/main" id="{7D42681A-9FFF-EA98-3E8E-07019113A796}"/>
+                <a16:creationId xmlns:a16="http://schemas.microsoft.com/office/drawing/2014/main" id="{AEFC4252-E0D2-5564-EAB8-CA3D4C717770}"/>
               </a:ext>
             </a:extLst>
           </p:cNvPr>
@@ -712,7 +1038,7 @@
           <p:cNvPr id="6" name="Foliennummernplatzhalter 5">
             <a:extLst>
               <a:ext uri="{FF2B5EF4-FFF2-40B4-BE49-F238E27FC236}">
-                <a16:creationId xmlns:a16="http://schemas.microsoft.com/office/drawing/2014/main" id="{649181FD-4565-E445-CD20-302DDC48760A}"/>
+                <a16:creationId xmlns:a16="http://schemas.microsoft.com/office/drawing/2014/main" id="{2743B337-F1AA-BC8F-B517-FC386A12A0BC}"/>
               </a:ext>
             </a:extLst>
           </p:cNvPr>
@@ -728,7 +1054,7 @@
           <a:bodyPr/>
           <a:lstStyle/>
           <a:p>
-            <a:fld id="{0EFEE498-A838-455C-A0C1-5F48ABA5D83C}" type="slidenum">
+            <a:fld id="{D661D80D-627D-4426-A21E-9522BBF9A65E}" type="slidenum">
               <a:rPr lang="de-DE" smtClean="0"/>
               <a:t>‹Nr.›</a:t>
             </a:fld>
@@ -739,7 +1065,7 @@
     </p:spTree>
     <p:extLst>
       <p:ext uri="{BB962C8B-B14F-4D97-AF65-F5344CB8AC3E}">
-        <p14:creationId xmlns:p14="http://schemas.microsoft.com/office/powerpoint/2010/main" val="1308415943"/>
+        <p14:creationId xmlns:p14="http://schemas.microsoft.com/office/powerpoint/2010/main" val="2561672391"/>
       </p:ext>
     </p:extLst>
   </p:cSld>
@@ -771,7 +1097,7 @@
           <p:cNvPr id="2" name="Vertikaler Titel 1">
             <a:extLst>
               <a:ext uri="{FF2B5EF4-FFF2-40B4-BE49-F238E27FC236}">
-                <a16:creationId xmlns:a16="http://schemas.microsoft.com/office/drawing/2014/main" id="{D50D10E1-798B-A70D-61CE-F949D78ECBF5}"/>
+                <a16:creationId xmlns:a16="http://schemas.microsoft.com/office/drawing/2014/main" id="{E045C9DD-42B4-CE9D-502A-B605C2FB6B8F}"/>
               </a:ext>
             </a:extLst>
           </p:cNvPr>
@@ -804,7 +1130,7 @@
           <p:cNvPr id="3" name="Vertikaler Textplatzhalter 2">
             <a:extLst>
               <a:ext uri="{FF2B5EF4-FFF2-40B4-BE49-F238E27FC236}">
-                <a16:creationId xmlns:a16="http://schemas.microsoft.com/office/drawing/2014/main" id="{F356C762-F384-D7CA-AA6D-0019582FF519}"/>
+                <a16:creationId xmlns:a16="http://schemas.microsoft.com/office/drawing/2014/main" id="{B21A4393-67A2-E636-0BFD-31C45087175A}"/>
               </a:ext>
             </a:extLst>
           </p:cNvPr>
@@ -866,7 +1192,7 @@
           <p:cNvPr id="4" name="Datumsplatzhalter 3">
             <a:extLst>
               <a:ext uri="{FF2B5EF4-FFF2-40B4-BE49-F238E27FC236}">
-                <a16:creationId xmlns:a16="http://schemas.microsoft.com/office/drawing/2014/main" id="{7EE913B4-B551-8F39-20B6-E647DF12C161}"/>
+                <a16:creationId xmlns:a16="http://schemas.microsoft.com/office/drawing/2014/main" id="{99DE5EEF-D3DD-7888-3A2A-539AC93EE73E}"/>
               </a:ext>
             </a:extLst>
           </p:cNvPr>
@@ -882,7 +1208,7 @@
           <a:bodyPr/>
           <a:lstStyle/>
           <a:p>
-            <a:fld id="{0F808190-ECEE-4405-8762-B79C9CB8530E}" type="datetimeFigureOut">
+            <a:fld id="{C50E988D-1B93-4C32-8AF0-3823B3639D11}" type="datetimeFigureOut">
               <a:rPr lang="de-DE" smtClean="0"/>
               <a:t>08.10.2026</a:t>
             </a:fld>
@@ -895,7 +1221,7 @@
           <p:cNvPr id="5" name="Fußzeilenplatzhalter 4">
             <a:extLst>
               <a:ext uri="{FF2B5EF4-FFF2-40B4-BE49-F238E27FC236}">
-                <a16:creationId xmlns:a16="http://schemas.microsoft.com/office/drawing/2014/main" id="{4117F3BD-B8E8-4A72-CF08-0F7D298EA89A}"/>
+                <a16:creationId xmlns:a16="http://schemas.microsoft.com/office/drawing/2014/main" id="{36F9B5E2-BD74-864A-8BBA-340BDFD9E305}"/>
               </a:ext>
             </a:extLst>
           </p:cNvPr>
@@ -920,7 +1246,7 @@
           <p:cNvPr id="6" name="Foliennummernplatzhalter 5">
             <a:extLst>
               <a:ext uri="{FF2B5EF4-FFF2-40B4-BE49-F238E27FC236}">
-                <a16:creationId xmlns:a16="http://schemas.microsoft.com/office/drawing/2014/main" id="{C77CAD4B-02AB-A95D-69EF-EE1BE6F35AA6}"/>
+                <a16:creationId xmlns:a16="http://schemas.microsoft.com/office/drawing/2014/main" id="{9CFED2B8-975A-1EA4-C2A5-D7E4B0947B7F}"/>
               </a:ext>
             </a:extLst>
           </p:cNvPr>
@@ -936,7 +1262,7 @@
           <a:bodyPr/>
           <a:lstStyle/>
           <a:p>
-            <a:fld id="{0EFEE498-A838-455C-A0C1-5F48ABA5D83C}" type="slidenum">
+            <a:fld id="{D661D80D-627D-4426-A21E-9522BBF9A65E}" type="slidenum">
               <a:rPr lang="de-DE" smtClean="0"/>
               <a:t>‹Nr.›</a:t>
             </a:fld>
@@ -947,7 +1273,7 @@
     </p:spTree>
     <p:extLst>
       <p:ext uri="{BB962C8B-B14F-4D97-AF65-F5344CB8AC3E}">
-        <p14:creationId xmlns:p14="http://schemas.microsoft.com/office/powerpoint/2010/main" val="2371347747"/>
+        <p14:creationId xmlns:p14="http://schemas.microsoft.com/office/powerpoint/2010/main" val="4164925941"/>
       </p:ext>
     </p:extLst>
   </p:cSld>
@@ -979,7 +1305,7 @@
           <p:cNvPr id="2" name="Titel 1">
             <a:extLst>
               <a:ext uri="{FF2B5EF4-FFF2-40B4-BE49-F238E27FC236}">
-                <a16:creationId xmlns:a16="http://schemas.microsoft.com/office/drawing/2014/main" id="{F0F91901-8F39-FF7F-CCA6-169CDACEEE47}"/>
+                <a16:creationId xmlns:a16="http://schemas.microsoft.com/office/drawing/2014/main" id="{FDD423AE-E3AC-36DB-4565-2CF359CD8FEE}"/>
               </a:ext>
             </a:extLst>
           </p:cNvPr>
@@ -1007,7 +1333,7 @@
           <p:cNvPr id="3" name="Inhaltsplatzhalter 2">
             <a:extLst>
               <a:ext uri="{FF2B5EF4-FFF2-40B4-BE49-F238E27FC236}">
-                <a16:creationId xmlns:a16="http://schemas.microsoft.com/office/drawing/2014/main" id="{9A796B3E-4D3F-423B-724A-0257150FD1E0}"/>
+                <a16:creationId xmlns:a16="http://schemas.microsoft.com/office/drawing/2014/main" id="{F7ECE5C7-9711-5A66-64D4-C2AFBCAF17B4}"/>
               </a:ext>
             </a:extLst>
           </p:cNvPr>
@@ -1064,7 +1390,7 @@
           <p:cNvPr id="4" name="Datumsplatzhalter 3">
             <a:extLst>
               <a:ext uri="{FF2B5EF4-FFF2-40B4-BE49-F238E27FC236}">
-                <a16:creationId xmlns:a16="http://schemas.microsoft.com/office/drawing/2014/main" id="{A6693095-02EB-1ED4-2138-DBCDF7383656}"/>
+                <a16:creationId xmlns:a16="http://schemas.microsoft.com/office/drawing/2014/main" id="{CC84657E-B482-19D5-FEEB-2317DAD59131}"/>
               </a:ext>
             </a:extLst>
           </p:cNvPr>
@@ -1080,7 +1406,7 @@
           <a:bodyPr/>
           <a:lstStyle/>
           <a:p>
-            <a:fld id="{0F808190-ECEE-4405-8762-B79C9CB8530E}" type="datetimeFigureOut">
+            <a:fld id="{C50E988D-1B93-4C32-8AF0-3823B3639D11}" type="datetimeFigureOut">
               <a:rPr lang="de-DE" smtClean="0"/>
               <a:t>08.10.2026</a:t>
             </a:fld>
@@ -1093,7 +1419,7 @@
           <p:cNvPr id="5" name="Fußzeilenplatzhalter 4">
             <a:extLst>
               <a:ext uri="{FF2B5EF4-FFF2-40B4-BE49-F238E27FC236}">
-                <a16:creationId xmlns:a16="http://schemas.microsoft.com/office/drawing/2014/main" id="{AE392AE2-EF0D-8965-0AE5-37E0EFECF4E3}"/>
+                <a16:creationId xmlns:a16="http://schemas.microsoft.com/office/drawing/2014/main" id="{2E4F4D61-46B2-B219-0737-913D144962CC}"/>
               </a:ext>
             </a:extLst>
           </p:cNvPr>
@@ -1118,7 +1444,7 @@
           <p:cNvPr id="6" name="Foliennummernplatzhalter 5">
             <a:extLst>
               <a:ext uri="{FF2B5EF4-FFF2-40B4-BE49-F238E27FC236}">
-                <a16:creationId xmlns:a16="http://schemas.microsoft.com/office/drawing/2014/main" id="{2138FF39-EBFE-318F-F0C5-31725B543C90}"/>
+                <a16:creationId xmlns:a16="http://schemas.microsoft.com/office/drawing/2014/main" id="{E141AB54-1919-BFE7-6F91-3898AF17C823}"/>
               </a:ext>
             </a:extLst>
           </p:cNvPr>
@@ -1134,7 +1460,7 @@
           <a:bodyPr/>
           <a:lstStyle/>
           <a:p>
-            <a:fld id="{0EFEE498-A838-455C-A0C1-5F48ABA5D83C}" type="slidenum">
+            <a:fld id="{D661D80D-627D-4426-A21E-9522BBF9A65E}" type="slidenum">
               <a:rPr lang="de-DE" smtClean="0"/>
               <a:t>‹Nr.›</a:t>
             </a:fld>
@@ -1145,7 +1471,7 @@
     </p:spTree>
     <p:extLst>
       <p:ext uri="{BB962C8B-B14F-4D97-AF65-F5344CB8AC3E}">
-        <p14:creationId xmlns:p14="http://schemas.microsoft.com/office/powerpoint/2010/main" val="4135558888"/>
+        <p14:creationId xmlns:p14="http://schemas.microsoft.com/office/powerpoint/2010/main" val="1753459272"/>
       </p:ext>
     </p:extLst>
   </p:cSld>
@@ -1177,7 +1503,7 @@
           <p:cNvPr id="2" name="Titel 1">
             <a:extLst>
               <a:ext uri="{FF2B5EF4-FFF2-40B4-BE49-F238E27FC236}">
-                <a16:creationId xmlns:a16="http://schemas.microsoft.com/office/drawing/2014/main" id="{5B4613E0-B031-BB09-3D86-4D71D6BF9A61}"/>
+                <a16:creationId xmlns:a16="http://schemas.microsoft.com/office/drawing/2014/main" id="{90117782-0654-7262-BD20-6AEB88F22EA6}"/>
               </a:ext>
             </a:extLst>
           </p:cNvPr>
@@ -1214,7 +1540,7 @@
           <p:cNvPr id="3" name="Textplatzhalter 2">
             <a:extLst>
               <a:ext uri="{FF2B5EF4-FFF2-40B4-BE49-F238E27FC236}">
-                <a16:creationId xmlns:a16="http://schemas.microsoft.com/office/drawing/2014/main" id="{D2D7C947-6287-4461-3A17-37C825CBC4FE}"/>
+                <a16:creationId xmlns:a16="http://schemas.microsoft.com/office/drawing/2014/main" id="{4F6DA940-36ED-30A7-B3C7-9F2FC840A6C8}"/>
               </a:ext>
             </a:extLst>
           </p:cNvPr>
@@ -1339,7 +1665,7 @@
           <p:cNvPr id="4" name="Datumsplatzhalter 3">
             <a:extLst>
               <a:ext uri="{FF2B5EF4-FFF2-40B4-BE49-F238E27FC236}">
-                <a16:creationId xmlns:a16="http://schemas.microsoft.com/office/drawing/2014/main" id="{CE1BC5D2-BEBF-8EF6-32C8-3BA32A099D20}"/>
+                <a16:creationId xmlns:a16="http://schemas.microsoft.com/office/drawing/2014/main" id="{AEA0869B-9992-FC8A-2956-4214E6B81375}"/>
               </a:ext>
             </a:extLst>
           </p:cNvPr>
@@ -1355,7 +1681,7 @@
           <a:bodyPr/>
           <a:lstStyle/>
           <a:p>
-            <a:fld id="{0F808190-ECEE-4405-8762-B79C9CB8530E}" type="datetimeFigureOut">
+            <a:fld id="{C50E988D-1B93-4C32-8AF0-3823B3639D11}" type="datetimeFigureOut">
               <a:rPr lang="de-DE" smtClean="0"/>
               <a:t>08.10.2026</a:t>
             </a:fld>
@@ -1368,7 +1694,7 @@
           <p:cNvPr id="5" name="Fußzeilenplatzhalter 4">
             <a:extLst>
               <a:ext uri="{FF2B5EF4-FFF2-40B4-BE49-F238E27FC236}">
-                <a16:creationId xmlns:a16="http://schemas.microsoft.com/office/drawing/2014/main" id="{4F16A645-6CF5-2372-AD8B-087048D14A14}"/>
+                <a16:creationId xmlns:a16="http://schemas.microsoft.com/office/drawing/2014/main" id="{8DC57148-4EEB-AE96-889E-289807CC18C6}"/>
               </a:ext>
             </a:extLst>
           </p:cNvPr>
@@ -1393,7 +1719,7 @@
           <p:cNvPr id="6" name="Foliennummernplatzhalter 5">
             <a:extLst>
               <a:ext uri="{FF2B5EF4-FFF2-40B4-BE49-F238E27FC236}">
-                <a16:creationId xmlns:a16="http://schemas.microsoft.com/office/drawing/2014/main" id="{81115614-93B9-AB86-1EC4-006CC254F053}"/>
+                <a16:creationId xmlns:a16="http://schemas.microsoft.com/office/drawing/2014/main" id="{C99A19E9-E021-7C06-B602-E3E12E3BD6BB}"/>
               </a:ext>
             </a:extLst>
           </p:cNvPr>
@@ -1409,7 +1735,7 @@
           <a:bodyPr/>
           <a:lstStyle/>
           <a:p>
-            <a:fld id="{0EFEE498-A838-455C-A0C1-5F48ABA5D83C}" type="slidenum">
+            <a:fld id="{D661D80D-627D-4426-A21E-9522BBF9A65E}" type="slidenum">
               <a:rPr lang="de-DE" smtClean="0"/>
               <a:t>‹Nr.›</a:t>
             </a:fld>
@@ -1420,7 +1746,7 @@
     </p:spTree>
     <p:extLst>
       <p:ext uri="{BB962C8B-B14F-4D97-AF65-F5344CB8AC3E}">
-        <p14:creationId xmlns:p14="http://schemas.microsoft.com/office/powerpoint/2010/main" val="2215033946"/>
+        <p14:creationId xmlns:p14="http://schemas.microsoft.com/office/powerpoint/2010/main" val="1166100456"/>
       </p:ext>
     </p:extLst>
   </p:cSld>
@@ -1452,7 +1778,7 @@
           <p:cNvPr id="2" name="Titel 1">
             <a:extLst>
               <a:ext uri="{FF2B5EF4-FFF2-40B4-BE49-F238E27FC236}">
-                <a16:creationId xmlns:a16="http://schemas.microsoft.com/office/drawing/2014/main" id="{727DB456-2863-3480-7090-A9FADF07F797}"/>
+                <a16:creationId xmlns:a16="http://schemas.microsoft.com/office/drawing/2014/main" id="{D77EE149-EABE-FBA2-5CF5-2E6EC06B335B}"/>
               </a:ext>
             </a:extLst>
           </p:cNvPr>
@@ -1480,7 +1806,7 @@
           <p:cNvPr id="3" name="Inhaltsplatzhalter 2">
             <a:extLst>
               <a:ext uri="{FF2B5EF4-FFF2-40B4-BE49-F238E27FC236}">
-                <a16:creationId xmlns:a16="http://schemas.microsoft.com/office/drawing/2014/main" id="{13820E33-1DF4-C86C-40F7-A0ACC32A67A1}"/>
+                <a16:creationId xmlns:a16="http://schemas.microsoft.com/office/drawing/2014/main" id="{F0B8322D-AD96-9968-45C0-AF8C6FF190BA}"/>
               </a:ext>
             </a:extLst>
           </p:cNvPr>
@@ -1542,7 +1868,7 @@
           <p:cNvPr id="4" name="Inhaltsplatzhalter 3">
             <a:extLst>
               <a:ext uri="{FF2B5EF4-FFF2-40B4-BE49-F238E27FC236}">
-                <a16:creationId xmlns:a16="http://schemas.microsoft.com/office/drawing/2014/main" id="{A6BF2CF0-8767-C2D8-01BE-62F26D9FEE94}"/>
+                <a16:creationId xmlns:a16="http://schemas.microsoft.com/office/drawing/2014/main" id="{8E85FB57-E14C-3279-B2CE-A473DAA68D25}"/>
               </a:ext>
             </a:extLst>
           </p:cNvPr>
@@ -1604,7 +1930,7 @@
           <p:cNvPr id="5" name="Datumsplatzhalter 4">
             <a:extLst>
               <a:ext uri="{FF2B5EF4-FFF2-40B4-BE49-F238E27FC236}">
-                <a16:creationId xmlns:a16="http://schemas.microsoft.com/office/drawing/2014/main" id="{BA8F8CA7-4C55-0A9E-29C8-D49405CA63A5}"/>
+                <a16:creationId xmlns:a16="http://schemas.microsoft.com/office/drawing/2014/main" id="{2F91D9A9-04D4-A501-A013-58CEFF34AC9A}"/>
               </a:ext>
             </a:extLst>
           </p:cNvPr>
@@ -1620,7 +1946,7 @@
           <a:bodyPr/>
           <a:lstStyle/>
           <a:p>
-            <a:fld id="{0F808190-ECEE-4405-8762-B79C9CB8530E}" type="datetimeFigureOut">
+            <a:fld id="{C50E988D-1B93-4C32-8AF0-3823B3639D11}" type="datetimeFigureOut">
               <a:rPr lang="de-DE" smtClean="0"/>
               <a:t>08.10.2026</a:t>
             </a:fld>
@@ -1633,7 +1959,7 @@
           <p:cNvPr id="6" name="Fußzeilenplatzhalter 5">
             <a:extLst>
               <a:ext uri="{FF2B5EF4-FFF2-40B4-BE49-F238E27FC236}">
-                <a16:creationId xmlns:a16="http://schemas.microsoft.com/office/drawing/2014/main" id="{530DBED7-10D9-BE55-5E77-2D97D23D6609}"/>
+                <a16:creationId xmlns:a16="http://schemas.microsoft.com/office/drawing/2014/main" id="{DEB5234D-D315-D20F-C723-0B02D5F3778A}"/>
               </a:ext>
             </a:extLst>
           </p:cNvPr>
@@ -1658,7 +1984,7 @@
           <p:cNvPr id="7" name="Foliennummernplatzhalter 6">
             <a:extLst>
               <a:ext uri="{FF2B5EF4-FFF2-40B4-BE49-F238E27FC236}">
-                <a16:creationId xmlns:a16="http://schemas.microsoft.com/office/drawing/2014/main" id="{66B40A09-7B0A-B6A2-2924-DA119BD165BC}"/>
+                <a16:creationId xmlns:a16="http://schemas.microsoft.com/office/drawing/2014/main" id="{D4636249-6ECE-8716-580D-BB871961556F}"/>
               </a:ext>
             </a:extLst>
           </p:cNvPr>
@@ -1674,7 +2000,7 @@
           <a:bodyPr/>
           <a:lstStyle/>
           <a:p>
-            <a:fld id="{0EFEE498-A838-455C-A0C1-5F48ABA5D83C}" type="slidenum">
+            <a:fld id="{D661D80D-627D-4426-A21E-9522BBF9A65E}" type="slidenum">
               <a:rPr lang="de-DE" smtClean="0"/>
               <a:t>‹Nr.›</a:t>
             </a:fld>
@@ -1685,7 +2011,7 @@
     </p:spTree>
     <p:extLst>
       <p:ext uri="{BB962C8B-B14F-4D97-AF65-F5344CB8AC3E}">
-        <p14:creationId xmlns:p14="http://schemas.microsoft.com/office/powerpoint/2010/main" val="579186686"/>
+        <p14:creationId xmlns:p14="http://schemas.microsoft.com/office/powerpoint/2010/main" val="3705605874"/>
       </p:ext>
     </p:extLst>
   </p:cSld>
@@ -1717,7 +2043,7 @@
           <p:cNvPr id="2" name="Titel 1">
             <a:extLst>
               <a:ext uri="{FF2B5EF4-FFF2-40B4-BE49-F238E27FC236}">
-                <a16:creationId xmlns:a16="http://schemas.microsoft.com/office/drawing/2014/main" id="{2A466955-E2EE-C428-F132-08C01E79DFA7}"/>
+                <a16:creationId xmlns:a16="http://schemas.microsoft.com/office/drawing/2014/main" id="{93D99BFD-B012-28C5-8B67-D62D44AB091D}"/>
               </a:ext>
             </a:extLst>
           </p:cNvPr>
@@ -1750,7 +2076,7 @@
           <p:cNvPr id="3" name="Textplatzhalter 2">
             <a:extLst>
               <a:ext uri="{FF2B5EF4-FFF2-40B4-BE49-F238E27FC236}">
-                <a16:creationId xmlns:a16="http://schemas.microsoft.com/office/drawing/2014/main" id="{DD6E4EFF-10CB-4156-EFA7-5B52AF8B5806}"/>
+                <a16:creationId xmlns:a16="http://schemas.microsoft.com/office/drawing/2014/main" id="{4A8329C9-CDAF-31D9-F2E5-0579175FC75E}"/>
               </a:ext>
             </a:extLst>
           </p:cNvPr>
@@ -1821,7 +2147,7 @@
           <p:cNvPr id="4" name="Inhaltsplatzhalter 3">
             <a:extLst>
               <a:ext uri="{FF2B5EF4-FFF2-40B4-BE49-F238E27FC236}">
-                <a16:creationId xmlns:a16="http://schemas.microsoft.com/office/drawing/2014/main" id="{C7029288-9AC9-D28C-5B85-BB4D435C40B7}"/>
+                <a16:creationId xmlns:a16="http://schemas.microsoft.com/office/drawing/2014/main" id="{D8D7C2CF-2F75-4A5F-15FB-B95B3780A46B}"/>
               </a:ext>
             </a:extLst>
           </p:cNvPr>
@@ -1883,7 +2209,7 @@
           <p:cNvPr id="5" name="Textplatzhalter 4">
             <a:extLst>
               <a:ext uri="{FF2B5EF4-FFF2-40B4-BE49-F238E27FC236}">
-                <a16:creationId xmlns:a16="http://schemas.microsoft.com/office/drawing/2014/main" id="{CCD134E9-EB26-C6B3-B8C6-4984B0B77E29}"/>
+                <a16:creationId xmlns:a16="http://schemas.microsoft.com/office/drawing/2014/main" id="{4024329A-1DB1-F63E-54DC-BE68570D0E29}"/>
               </a:ext>
             </a:extLst>
           </p:cNvPr>
@@ -1954,7 +2280,7 @@
           <p:cNvPr id="6" name="Inhaltsplatzhalter 5">
             <a:extLst>
               <a:ext uri="{FF2B5EF4-FFF2-40B4-BE49-F238E27FC236}">
-                <a16:creationId xmlns:a16="http://schemas.microsoft.com/office/drawing/2014/main" id="{764DC9F5-55D5-B857-C5E4-A0DDEDEA9787}"/>
+                <a16:creationId xmlns:a16="http://schemas.microsoft.com/office/drawing/2014/main" id="{8F62F178-F223-A317-AA94-7E1487D89FCE}"/>
               </a:ext>
             </a:extLst>
           </p:cNvPr>
@@ -2016,7 +2342,7 @@
           <p:cNvPr id="7" name="Datumsplatzhalter 6">
             <a:extLst>
               <a:ext uri="{FF2B5EF4-FFF2-40B4-BE49-F238E27FC236}">
-                <a16:creationId xmlns:a16="http://schemas.microsoft.com/office/drawing/2014/main" id="{51E117FF-6E7F-0D05-50F9-3C448665283F}"/>
+                <a16:creationId xmlns:a16="http://schemas.microsoft.com/office/drawing/2014/main" id="{B6AB61E4-371B-354F-2927-41529A6C20DC}"/>
               </a:ext>
             </a:extLst>
           </p:cNvPr>
@@ -2032,7 +2358,7 @@
           <a:bodyPr/>
           <a:lstStyle/>
           <a:p>
-            <a:fld id="{0F808190-ECEE-4405-8762-B79C9CB8530E}" type="datetimeFigureOut">
+            <a:fld id="{C50E988D-1B93-4C32-8AF0-3823B3639D11}" type="datetimeFigureOut">
               <a:rPr lang="de-DE" smtClean="0"/>
               <a:t>08.10.2026</a:t>
             </a:fld>
@@ -2045,7 +2371,7 @@
           <p:cNvPr id="8" name="Fußzeilenplatzhalter 7">
             <a:extLst>
               <a:ext uri="{FF2B5EF4-FFF2-40B4-BE49-F238E27FC236}">
-                <a16:creationId xmlns:a16="http://schemas.microsoft.com/office/drawing/2014/main" id="{39C89894-EE73-262E-C277-136DCC8CC3B0}"/>
+                <a16:creationId xmlns:a16="http://schemas.microsoft.com/office/drawing/2014/main" id="{3649C9F5-70CA-5CB8-BB0B-C8A22BFE9118}"/>
               </a:ext>
             </a:extLst>
           </p:cNvPr>
@@ -2070,7 +2396,7 @@
           <p:cNvPr id="9" name="Foliennummernplatzhalter 8">
             <a:extLst>
               <a:ext uri="{FF2B5EF4-FFF2-40B4-BE49-F238E27FC236}">
-                <a16:creationId xmlns:a16="http://schemas.microsoft.com/office/drawing/2014/main" id="{4F2D2A99-F754-B526-0B0E-56541FBB1D05}"/>
+                <a16:creationId xmlns:a16="http://schemas.microsoft.com/office/drawing/2014/main" id="{57C66C5D-069F-88F2-BFEB-E15FCC9BB966}"/>
               </a:ext>
             </a:extLst>
           </p:cNvPr>
@@ -2086,7 +2412,7 @@
           <a:bodyPr/>
           <a:lstStyle/>
           <a:p>
-            <a:fld id="{0EFEE498-A838-455C-A0C1-5F48ABA5D83C}" type="slidenum">
+            <a:fld id="{D661D80D-627D-4426-A21E-9522BBF9A65E}" type="slidenum">
               <a:rPr lang="de-DE" smtClean="0"/>
               <a:t>‹Nr.›</a:t>
             </a:fld>
@@ -2097,7 +2423,7 @@
     </p:spTree>
     <p:extLst>
       <p:ext uri="{BB962C8B-B14F-4D97-AF65-F5344CB8AC3E}">
-        <p14:creationId xmlns:p14="http://schemas.microsoft.com/office/powerpoint/2010/main" val="733101830"/>
+        <p14:creationId xmlns:p14="http://schemas.microsoft.com/office/powerpoint/2010/main" val="2470845411"/>
       </p:ext>
     </p:extLst>
   </p:cSld>
@@ -2129,7 +2455,7 @@
           <p:cNvPr id="2" name="Titel 1">
             <a:extLst>
               <a:ext uri="{FF2B5EF4-FFF2-40B4-BE49-F238E27FC236}">
-                <a16:creationId xmlns:a16="http://schemas.microsoft.com/office/drawing/2014/main" id="{347D2648-B9C5-E20B-C0AF-61927F470F6F}"/>
+                <a16:creationId xmlns:a16="http://schemas.microsoft.com/office/drawing/2014/main" id="{575DC0EE-4A31-4A84-59A8-EAB35D48ECBC}"/>
               </a:ext>
             </a:extLst>
           </p:cNvPr>
@@ -2157,7 +2483,7 @@
           <p:cNvPr id="3" name="Datumsplatzhalter 2">
             <a:extLst>
               <a:ext uri="{FF2B5EF4-FFF2-40B4-BE49-F238E27FC236}">
-                <a16:creationId xmlns:a16="http://schemas.microsoft.com/office/drawing/2014/main" id="{B72A27CC-1F2B-8CB2-390A-DFBDDBBA81C4}"/>
+                <a16:creationId xmlns:a16="http://schemas.microsoft.com/office/drawing/2014/main" id="{2C8867E5-C243-229A-DC68-D358477CBB7F}"/>
               </a:ext>
             </a:extLst>
           </p:cNvPr>
@@ -2173,7 +2499,7 @@
           <a:bodyPr/>
           <a:lstStyle/>
           <a:p>
-            <a:fld id="{0F808190-ECEE-4405-8762-B79C9CB8530E}" type="datetimeFigureOut">
+            <a:fld id="{C50E988D-1B93-4C32-8AF0-3823B3639D11}" type="datetimeFigureOut">
               <a:rPr lang="de-DE" smtClean="0"/>
               <a:t>08.10.2026</a:t>
             </a:fld>
@@ -2186,7 +2512,7 @@
           <p:cNvPr id="4" name="Fußzeilenplatzhalter 3">
             <a:extLst>
               <a:ext uri="{FF2B5EF4-FFF2-40B4-BE49-F238E27FC236}">
-                <a16:creationId xmlns:a16="http://schemas.microsoft.com/office/drawing/2014/main" id="{AB7E7F46-852C-6A9C-E03D-7CB8BAED2CF6}"/>
+                <a16:creationId xmlns:a16="http://schemas.microsoft.com/office/drawing/2014/main" id="{F797C634-DA56-EF9E-E64F-ABD7F9255268}"/>
               </a:ext>
             </a:extLst>
           </p:cNvPr>
@@ -2211,7 +2537,7 @@
           <p:cNvPr id="5" name="Foliennummernplatzhalter 4">
             <a:extLst>
               <a:ext uri="{FF2B5EF4-FFF2-40B4-BE49-F238E27FC236}">
-                <a16:creationId xmlns:a16="http://schemas.microsoft.com/office/drawing/2014/main" id="{483B5D59-CA79-F192-4C1A-46D634720FBF}"/>
+                <a16:creationId xmlns:a16="http://schemas.microsoft.com/office/drawing/2014/main" id="{2FBDE2AA-C003-C1F0-8956-9958332AB734}"/>
               </a:ext>
             </a:extLst>
           </p:cNvPr>
@@ -2227,7 +2553,7 @@
           <a:bodyPr/>
           <a:lstStyle/>
           <a:p>
-            <a:fld id="{0EFEE498-A838-455C-A0C1-5F48ABA5D83C}" type="slidenum">
+            <a:fld id="{D661D80D-627D-4426-A21E-9522BBF9A65E}" type="slidenum">
               <a:rPr lang="de-DE" smtClean="0"/>
               <a:t>‹Nr.›</a:t>
             </a:fld>
@@ -2238,7 +2564,7 @@
     </p:spTree>
     <p:extLst>
       <p:ext uri="{BB962C8B-B14F-4D97-AF65-F5344CB8AC3E}">
-        <p14:creationId xmlns:p14="http://schemas.microsoft.com/office/powerpoint/2010/main" val="3951353144"/>
+        <p14:creationId xmlns:p14="http://schemas.microsoft.com/office/powerpoint/2010/main" val="500387353"/>
       </p:ext>
     </p:extLst>
   </p:cSld>
@@ -2270,7 +2596,7 @@
           <p:cNvPr id="2" name="Datumsplatzhalter 1">
             <a:extLst>
               <a:ext uri="{FF2B5EF4-FFF2-40B4-BE49-F238E27FC236}">
-                <a16:creationId xmlns:a16="http://schemas.microsoft.com/office/drawing/2014/main" id="{907A205A-753E-433C-5657-6DF44EF7444F}"/>
+                <a16:creationId xmlns:a16="http://schemas.microsoft.com/office/drawing/2014/main" id="{BD336B7D-EEDD-C075-450C-8E1AEA202057}"/>
               </a:ext>
             </a:extLst>
           </p:cNvPr>
@@ -2286,7 +2612,7 @@
           <a:bodyPr/>
           <a:lstStyle/>
           <a:p>
-            <a:fld id="{0F808190-ECEE-4405-8762-B79C9CB8530E}" type="datetimeFigureOut">
+            <a:fld id="{C50E988D-1B93-4C32-8AF0-3823B3639D11}" type="datetimeFigureOut">
               <a:rPr lang="de-DE" smtClean="0"/>
               <a:t>08.10.2026</a:t>
             </a:fld>
@@ -2299,7 +2625,7 @@
           <p:cNvPr id="3" name="Fußzeilenplatzhalter 2">
             <a:extLst>
               <a:ext uri="{FF2B5EF4-FFF2-40B4-BE49-F238E27FC236}">
-                <a16:creationId xmlns:a16="http://schemas.microsoft.com/office/drawing/2014/main" id="{FCB7D7A6-88C8-EEDE-70B7-6762764C869F}"/>
+                <a16:creationId xmlns:a16="http://schemas.microsoft.com/office/drawing/2014/main" id="{0305AA78-DC27-6BB8-0B18-8D11310921CA}"/>
               </a:ext>
             </a:extLst>
           </p:cNvPr>
@@ -2324,7 +2650,7 @@
           <p:cNvPr id="4" name="Foliennummernplatzhalter 3">
             <a:extLst>
               <a:ext uri="{FF2B5EF4-FFF2-40B4-BE49-F238E27FC236}">
-                <a16:creationId xmlns:a16="http://schemas.microsoft.com/office/drawing/2014/main" id="{2906DBE4-F22D-C3B8-AB0D-76EC6E80BB67}"/>
+                <a16:creationId xmlns:a16="http://schemas.microsoft.com/office/drawing/2014/main" id="{554536F3-3F0B-ED8A-78ED-8BA8A0708DB5}"/>
               </a:ext>
             </a:extLst>
           </p:cNvPr>
@@ -2340,7 +2666,7 @@
           <a:bodyPr/>
           <a:lstStyle/>
           <a:p>
-            <a:fld id="{0EFEE498-A838-455C-A0C1-5F48ABA5D83C}" type="slidenum">
+            <a:fld id="{D661D80D-627D-4426-A21E-9522BBF9A65E}" type="slidenum">
               <a:rPr lang="de-DE" smtClean="0"/>
               <a:t>‹Nr.›</a:t>
             </a:fld>
@@ -2351,7 +2677,7 @@
     </p:spTree>
     <p:extLst>
       <p:ext uri="{BB962C8B-B14F-4D97-AF65-F5344CB8AC3E}">
-        <p14:creationId xmlns:p14="http://schemas.microsoft.com/office/powerpoint/2010/main" val="2156333900"/>
+        <p14:creationId xmlns:p14="http://schemas.microsoft.com/office/powerpoint/2010/main" val="1174860802"/>
       </p:ext>
     </p:extLst>
   </p:cSld>
@@ -2383,7 +2709,7 @@
           <p:cNvPr id="2" name="Titel 1">
             <a:extLst>
               <a:ext uri="{FF2B5EF4-FFF2-40B4-BE49-F238E27FC236}">
-                <a16:creationId xmlns:a16="http://schemas.microsoft.com/office/drawing/2014/main" id="{39986C57-B983-3B3D-2A4A-A4860D70FE4A}"/>
+                <a16:creationId xmlns:a16="http://schemas.microsoft.com/office/drawing/2014/main" id="{9F9846FE-409F-DE6C-918B-05A03C95BC03}"/>
               </a:ext>
             </a:extLst>
           </p:cNvPr>
@@ -2420,7 +2746,7 @@
           <p:cNvPr id="3" name="Inhaltsplatzhalter 2">
             <a:extLst>
               <a:ext uri="{FF2B5EF4-FFF2-40B4-BE49-F238E27FC236}">
-                <a16:creationId xmlns:a16="http://schemas.microsoft.com/office/drawing/2014/main" id="{2B9795F1-8858-7CD6-1EFA-A8BFCF6046C3}"/>
+                <a16:creationId xmlns:a16="http://schemas.microsoft.com/office/drawing/2014/main" id="{E3EC7551-CE6E-6F2D-BFD1-193D8798115F}"/>
               </a:ext>
             </a:extLst>
           </p:cNvPr>
@@ -2510,7 +2836,7 @@
           <p:cNvPr id="4" name="Textplatzhalter 3">
             <a:extLst>
               <a:ext uri="{FF2B5EF4-FFF2-40B4-BE49-F238E27FC236}">
-                <a16:creationId xmlns:a16="http://schemas.microsoft.com/office/drawing/2014/main" id="{87416BBC-09AE-7367-55D5-CE42232D640E}"/>
+                <a16:creationId xmlns:a16="http://schemas.microsoft.com/office/drawing/2014/main" id="{AF212A25-6C38-7AD6-8A7D-6D1BD95FE9D4}"/>
               </a:ext>
             </a:extLst>
           </p:cNvPr>
@@ -2581,7 +2907,7 @@
           <p:cNvPr id="5" name="Datumsplatzhalter 4">
             <a:extLst>
               <a:ext uri="{FF2B5EF4-FFF2-40B4-BE49-F238E27FC236}">
-                <a16:creationId xmlns:a16="http://schemas.microsoft.com/office/drawing/2014/main" id="{FBC93DA8-54B8-71E2-1559-D16D128FF849}"/>
+                <a16:creationId xmlns:a16="http://schemas.microsoft.com/office/drawing/2014/main" id="{B2396382-38CF-D107-E64B-F044CEAB789C}"/>
               </a:ext>
             </a:extLst>
           </p:cNvPr>
@@ -2597,7 +2923,7 @@
           <a:bodyPr/>
           <a:lstStyle/>
           <a:p>
-            <a:fld id="{0F808190-ECEE-4405-8762-B79C9CB8530E}" type="datetimeFigureOut">
+            <a:fld id="{C50E988D-1B93-4C32-8AF0-3823B3639D11}" type="datetimeFigureOut">
               <a:rPr lang="de-DE" smtClean="0"/>
               <a:t>08.10.2026</a:t>
             </a:fld>
@@ -2610,7 +2936,7 @@
           <p:cNvPr id="6" name="Fußzeilenplatzhalter 5">
             <a:extLst>
               <a:ext uri="{FF2B5EF4-FFF2-40B4-BE49-F238E27FC236}">
-                <a16:creationId xmlns:a16="http://schemas.microsoft.com/office/drawing/2014/main" id="{B872A153-3D74-E3F2-6CEF-6F088E823648}"/>
+                <a16:creationId xmlns:a16="http://schemas.microsoft.com/office/drawing/2014/main" id="{08AF71E4-6F53-D49E-F3BA-12F85FF34E86}"/>
               </a:ext>
             </a:extLst>
           </p:cNvPr>
@@ -2635,7 +2961,7 @@
           <p:cNvPr id="7" name="Foliennummernplatzhalter 6">
             <a:extLst>
               <a:ext uri="{FF2B5EF4-FFF2-40B4-BE49-F238E27FC236}">
-                <a16:creationId xmlns:a16="http://schemas.microsoft.com/office/drawing/2014/main" id="{AB834821-6B96-287A-641F-1C014631E345}"/>
+                <a16:creationId xmlns:a16="http://schemas.microsoft.com/office/drawing/2014/main" id="{AABA0D38-1385-1891-38B6-133C7E9F5E41}"/>
               </a:ext>
             </a:extLst>
           </p:cNvPr>
@@ -2651,7 +2977,7 @@
           <a:bodyPr/>
           <a:lstStyle/>
           <a:p>
-            <a:fld id="{0EFEE498-A838-455C-A0C1-5F48ABA5D83C}" type="slidenum">
+            <a:fld id="{D661D80D-627D-4426-A21E-9522BBF9A65E}" type="slidenum">
               <a:rPr lang="de-DE" smtClean="0"/>
               <a:t>‹Nr.›</a:t>
             </a:fld>
@@ -2662,7 +2988,7 @@
     </p:spTree>
     <p:extLst>
       <p:ext uri="{BB962C8B-B14F-4D97-AF65-F5344CB8AC3E}">
-        <p14:creationId xmlns:p14="http://schemas.microsoft.com/office/powerpoint/2010/main" val="3652666256"/>
+        <p14:creationId xmlns:p14="http://schemas.microsoft.com/office/powerpoint/2010/main" val="1551957198"/>
       </p:ext>
     </p:extLst>
   </p:cSld>
@@ -2694,7 +3020,7 @@
           <p:cNvPr id="2" name="Titel 1">
             <a:extLst>
               <a:ext uri="{FF2B5EF4-FFF2-40B4-BE49-F238E27FC236}">
-                <a16:creationId xmlns:a16="http://schemas.microsoft.com/office/drawing/2014/main" id="{C8EB9A77-819F-03EE-2C5A-B45A9C4B3CE1}"/>
+                <a16:creationId xmlns:a16="http://schemas.microsoft.com/office/drawing/2014/main" id="{B14C5D15-A283-AB84-48B0-9D62418D0753}"/>
               </a:ext>
             </a:extLst>
           </p:cNvPr>
@@ -2731,7 +3057,7 @@
           <p:cNvPr id="3" name="Bildplatzhalter 2">
             <a:extLst>
               <a:ext uri="{FF2B5EF4-FFF2-40B4-BE49-F238E27FC236}">
-                <a16:creationId xmlns:a16="http://schemas.microsoft.com/office/drawing/2014/main" id="{96620AA1-4680-3083-AF63-3DF294CA072B}"/>
+                <a16:creationId xmlns:a16="http://schemas.microsoft.com/office/drawing/2014/main" id="{AD7F09E0-20B5-0CDC-7D9C-13C1DA9B81EE}"/>
               </a:ext>
             </a:extLst>
           </p:cNvPr>
@@ -2798,7 +3124,7 @@
           <p:cNvPr id="4" name="Textplatzhalter 3">
             <a:extLst>
               <a:ext uri="{FF2B5EF4-FFF2-40B4-BE49-F238E27FC236}">
-                <a16:creationId xmlns:a16="http://schemas.microsoft.com/office/drawing/2014/main" id="{74118095-1B02-D8A1-6422-700F175C3587}"/>
+                <a16:creationId xmlns:a16="http://schemas.microsoft.com/office/drawing/2014/main" id="{D808D572-40FB-57CA-2BEC-3320EAEEB8A7}"/>
               </a:ext>
             </a:extLst>
           </p:cNvPr>
@@ -2869,7 +3195,7 @@
           <p:cNvPr id="5" name="Datumsplatzhalter 4">
             <a:extLst>
               <a:ext uri="{FF2B5EF4-FFF2-40B4-BE49-F238E27FC236}">
-                <a16:creationId xmlns:a16="http://schemas.microsoft.com/office/drawing/2014/main" id="{EC5811F6-B15C-0A03-9410-A8823B6D1122}"/>
+                <a16:creationId xmlns:a16="http://schemas.microsoft.com/office/drawing/2014/main" id="{AD205A0F-DC69-B9E8-E1DF-6BEE31FC5D77}"/>
               </a:ext>
             </a:extLst>
           </p:cNvPr>
@@ -2885,7 +3211,7 @@
           <a:bodyPr/>
           <a:lstStyle/>
           <a:p>
-            <a:fld id="{0F808190-ECEE-4405-8762-B79C9CB8530E}" type="datetimeFigureOut">
+            <a:fld id="{C50E988D-1B93-4C32-8AF0-3823B3639D11}" type="datetimeFigureOut">
               <a:rPr lang="de-DE" smtClean="0"/>
               <a:t>08.10.2026</a:t>
             </a:fld>
@@ -2898,7 +3224,7 @@
           <p:cNvPr id="6" name="Fußzeilenplatzhalter 5">
             <a:extLst>
               <a:ext uri="{FF2B5EF4-FFF2-40B4-BE49-F238E27FC236}">
-                <a16:creationId xmlns:a16="http://schemas.microsoft.com/office/drawing/2014/main" id="{3692BC28-94C0-DBBE-9CCD-44C5AA2BD201}"/>
+                <a16:creationId xmlns:a16="http://schemas.microsoft.com/office/drawing/2014/main" id="{72297E28-7C52-42EB-D582-5C4669CBFBE4}"/>
               </a:ext>
             </a:extLst>
           </p:cNvPr>
@@ -2923,7 +3249,7 @@
           <p:cNvPr id="7" name="Foliennummernplatzhalter 6">
             <a:extLst>
               <a:ext uri="{FF2B5EF4-FFF2-40B4-BE49-F238E27FC236}">
-                <a16:creationId xmlns:a16="http://schemas.microsoft.com/office/drawing/2014/main" id="{9B5E5C24-47B8-A344-28E0-A81C1F24EBE4}"/>
+                <a16:creationId xmlns:a16="http://schemas.microsoft.com/office/drawing/2014/main" id="{B9D11BB2-A711-71DB-9872-31C0EBE0C954}"/>
               </a:ext>
             </a:extLst>
           </p:cNvPr>
@@ -2939,7 +3265,7 @@
           <a:bodyPr/>
           <a:lstStyle/>
           <a:p>
-            <a:fld id="{0EFEE498-A838-455C-A0C1-5F48ABA5D83C}" type="slidenum">
+            <a:fld id="{D661D80D-627D-4426-A21E-9522BBF9A65E}" type="slidenum">
               <a:rPr lang="de-DE" smtClean="0"/>
               <a:t>‹Nr.›</a:t>
             </a:fld>
@@ -2950,7 +3276,7 @@
     </p:spTree>
     <p:extLst>
       <p:ext uri="{BB962C8B-B14F-4D97-AF65-F5344CB8AC3E}">
-        <p14:creationId xmlns:p14="http://schemas.microsoft.com/office/powerpoint/2010/main" val="391892691"/>
+        <p14:creationId xmlns:p14="http://schemas.microsoft.com/office/powerpoint/2010/main" val="3926038635"/>
       </p:ext>
     </p:extLst>
   </p:cSld>
@@ -2987,7 +3313,7 @@
           <p:cNvPr id="2" name="Titelplatzhalter 1">
             <a:extLst>
               <a:ext uri="{FF2B5EF4-FFF2-40B4-BE49-F238E27FC236}">
-                <a16:creationId xmlns:a16="http://schemas.microsoft.com/office/drawing/2014/main" id="{7EAAE2C2-D4A7-E45A-B8A0-EE90D5A1ABEA}"/>
+                <a16:creationId xmlns:a16="http://schemas.microsoft.com/office/drawing/2014/main" id="{C5B1B202-45FD-5FE3-0E33-C1320C80FB32}"/>
               </a:ext>
             </a:extLst>
           </p:cNvPr>
@@ -3025,7 +3351,7 @@
           <p:cNvPr id="3" name="Textplatzhalter 2">
             <a:extLst>
               <a:ext uri="{FF2B5EF4-FFF2-40B4-BE49-F238E27FC236}">
-                <a16:creationId xmlns:a16="http://schemas.microsoft.com/office/drawing/2014/main" id="{AD207141-B982-FA5C-43F5-E026D786C720}"/>
+                <a16:creationId xmlns:a16="http://schemas.microsoft.com/office/drawing/2014/main" id="{4C757D00-BF82-4A8A-0C4B-C45D765DB155}"/>
               </a:ext>
             </a:extLst>
           </p:cNvPr>
@@ -3092,7 +3418,7 @@
           <p:cNvPr id="4" name="Datumsplatzhalter 3">
             <a:extLst>
               <a:ext uri="{FF2B5EF4-FFF2-40B4-BE49-F238E27FC236}">
-                <a16:creationId xmlns:a16="http://schemas.microsoft.com/office/drawing/2014/main" id="{73CDCF69-51C6-8DCE-675D-F0E852842B5E}"/>
+                <a16:creationId xmlns:a16="http://schemas.microsoft.com/office/drawing/2014/main" id="{16DB34D9-E3A2-2816-2FE4-1ADA5D7C4003}"/>
               </a:ext>
             </a:extLst>
           </p:cNvPr>
@@ -3126,7 +3452,7 @@
             </a:lvl1pPr>
           </a:lstStyle>
           <a:p>
-            <a:fld id="{0F808190-ECEE-4405-8762-B79C9CB8530E}" type="datetimeFigureOut">
+            <a:fld id="{C50E988D-1B93-4C32-8AF0-3823B3639D11}" type="datetimeFigureOut">
               <a:rPr lang="de-DE" smtClean="0"/>
               <a:t>08.10.2026</a:t>
             </a:fld>
@@ -3139,7 +3465,7 @@
           <p:cNvPr id="5" name="Fußzeilenplatzhalter 4">
             <a:extLst>
               <a:ext uri="{FF2B5EF4-FFF2-40B4-BE49-F238E27FC236}">
-                <a16:creationId xmlns:a16="http://schemas.microsoft.com/office/drawing/2014/main" id="{B91BF911-A8EC-666E-A9F7-54B29E9D1984}"/>
+                <a16:creationId xmlns:a16="http://schemas.microsoft.com/office/drawing/2014/main" id="{A3FB7528-EAC1-7C0A-0713-69F564599AD2}"/>
               </a:ext>
             </a:extLst>
           </p:cNvPr>
@@ -3182,7 +3508,7 @@
           <p:cNvPr id="6" name="Foliennummernplatzhalter 5">
             <a:extLst>
               <a:ext uri="{FF2B5EF4-FFF2-40B4-BE49-F238E27FC236}">
-                <a16:creationId xmlns:a16="http://schemas.microsoft.com/office/drawing/2014/main" id="{BFE18BB4-7183-9146-7250-D09131EB5EE2}"/>
+                <a16:creationId xmlns:a16="http://schemas.microsoft.com/office/drawing/2014/main" id="{573A4660-B5D8-B245-C7F8-C8142A8E7ECC}"/>
               </a:ext>
             </a:extLst>
           </p:cNvPr>
@@ -3216,7 +3542,7 @@
             </a:lvl1pPr>
           </a:lstStyle>
           <a:p>
-            <a:fld id="{0EFEE498-A838-455C-A0C1-5F48ABA5D83C}" type="slidenum">
+            <a:fld id="{D661D80D-627D-4426-A21E-9522BBF9A65E}" type="slidenum">
               <a:rPr lang="de-DE" smtClean="0"/>
               <a:t>‹Nr.›</a:t>
             </a:fld>
@@ -3227,7 +3553,7 @@
     </p:spTree>
     <p:extLst>
       <p:ext uri="{BB962C8B-B14F-4D97-AF65-F5344CB8AC3E}">
-        <p14:creationId xmlns:p14="http://schemas.microsoft.com/office/powerpoint/2010/main" val="2225782392"/>
+        <p14:creationId xmlns:p14="http://schemas.microsoft.com/office/powerpoint/2010/main" val="3503745352"/>
       </p:ext>
     </p:extLst>
   </p:cSld>
@@ -3550,7 +3876,7 @@
           <p:cNvPr id="2" name="Textfeld 1">
             <a:extLst>
               <a:ext uri="{FF2B5EF4-FFF2-40B4-BE49-F238E27FC236}">
-                <a16:creationId xmlns:a16="http://schemas.microsoft.com/office/drawing/2014/main" id="{1DA5438B-4111-839F-A4A1-B38DB33DA9C8}"/>
+                <a16:creationId xmlns:a16="http://schemas.microsoft.com/office/drawing/2014/main" id="{2CE77F6C-BB73-01BE-97A0-2FD7351C16BE}"/>
               </a:ext>
             </a:extLst>
           </p:cNvPr>
@@ -3708,10 +4034,90 @@
         </mc:Choice>
         <mc:Fallback/>
       </mc:AlternateContent>
+      <mc:AlternateContent xmlns:mc="http://schemas.openxmlformats.org/markup-compatibility/2006">
+        <mc:Choice xmlns:p14="http://schemas.microsoft.com/office/powerpoint/2010/main" Requires="p14">
+          <p:contentPart p14:bwMode="auto" r:id="rIdInk9">
+            <p14:nvContentPartPr>
+              <p14:cNvPr id="208" name="Ink 9"/>
+              <p14:cNvContentPartPr/>
+              <p14:nvPr/>
+            </p14:nvContentPartPr>
+            <p14:xfrm>
+              <a:off x="9468000" y="648000"/>
+              <a:ext cx="2304000" cy="144000"/>
+            </p14:xfrm>
+          </p:contentPart>
+        </mc:Choice>
+        <mc:Fallback/>
+      </mc:AlternateContent>
+      <mc:AlternateContent xmlns:mc="http://schemas.openxmlformats.org/markup-compatibility/2006">
+        <mc:Choice xmlns:p14="http://schemas.microsoft.com/office/powerpoint/2010/main" Requires="p14">
+          <p:contentPart p14:bwMode="auto" r:id="rIdInk10">
+            <p14:nvContentPartPr>
+              <p14:cNvPr id="209" name="Ink 10"/>
+              <p14:cNvContentPartPr/>
+              <p14:nvPr/>
+            </p14:nvContentPartPr>
+            <p14:xfrm>
+              <a:off x="9468000" y="1368000"/>
+              <a:ext cx="2304000" cy="144000"/>
+            </p14:xfrm>
+          </p:contentPart>
+        </mc:Choice>
+        <mc:Fallback/>
+      </mc:AlternateContent>
+      <mc:AlternateContent xmlns:mc="http://schemas.openxmlformats.org/markup-compatibility/2006">
+        <mc:Choice xmlns:p14="http://schemas.microsoft.com/office/powerpoint/2010/main" Requires="p14">
+          <p:contentPart p14:bwMode="auto" r:id="rIdInk11">
+            <p14:nvContentPartPr>
+              <p14:cNvPr id="210" name="Ink 11"/>
+              <p14:cNvContentPartPr/>
+              <p14:nvPr/>
+            </p14:nvContentPartPr>
+            <p14:xfrm>
+              <a:off x="9468000" y="2088000"/>
+              <a:ext cx="2304000" cy="144000"/>
+            </p14:xfrm>
+          </p:contentPart>
+        </mc:Choice>
+        <mc:Fallback/>
+      </mc:AlternateContent>
+      <mc:AlternateContent xmlns:mc="http://schemas.openxmlformats.org/markup-compatibility/2006">
+        <mc:Choice xmlns:p14="http://schemas.microsoft.com/office/powerpoint/2010/main" Requires="p14">
+          <p:contentPart p14:bwMode="auto" r:id="rIdInk12">
+            <p14:nvContentPartPr>
+              <p14:cNvPr id="211" name="Ink 12"/>
+              <p14:cNvContentPartPr/>
+              <p14:nvPr/>
+            </p14:nvContentPartPr>
+            <p14:xfrm>
+              <a:off x="9468000" y="2808000"/>
+              <a:ext cx="2304000" cy="144000"/>
+            </p14:xfrm>
+          </p:contentPart>
+        </mc:Choice>
+        <mc:Fallback/>
+      </mc:AlternateContent>
+      <mc:AlternateContent xmlns:mc="http://schemas.openxmlformats.org/markup-compatibility/2006">
+        <mc:Choice xmlns:p14="http://schemas.microsoft.com/office/powerpoint/2010/main" Requires="p14">
+          <p:contentPart p14:bwMode="auto" r:id="rIdInk13">
+            <p14:nvContentPartPr>
+              <p14:cNvPr id="212" name="Ink 13"/>
+              <p14:cNvContentPartPr/>
+              <p14:nvPr/>
+            </p14:nvContentPartPr>
+            <p14:xfrm>
+              <a:off x="9486000" y="3546000"/>
+              <a:ext cx="2268000" cy="648000"/>
+            </p14:xfrm>
+          </p:contentPart>
+        </mc:Choice>
+        <mc:Fallback/>
+      </mc:AlternateContent>
     </p:spTree>
     <p:extLst>
       <p:ext uri="{BB962C8B-B14F-4D97-AF65-F5344CB8AC3E}">
-        <p14:creationId xmlns:p14="http://schemas.microsoft.com/office/powerpoint/2010/main" val="1453927514"/>
+        <p14:creationId xmlns:p14="http://schemas.microsoft.com/office/powerpoint/2010/main" val="2835428151"/>
       </p:ext>
     </p:extLst>
   </p:cSld>

</xml_diff>